<commit_message>
Ganti istilah error sistematis/acak dengan bahasa sederhana pada slide uji perilaku
Co-Authored-By: Claude Opus 5.5 <noreply@anthropic.com>
Claude-Session: https://claude.ai/code/session_01RwTK1q8JkWDwXbpfgwmLot
</commit_message>
<xml_diff>
--- a/Slide - Hasil Uji Parsial dan Penuh (slide lama, kalimat diperbaiki).pptx
+++ b/Slide - Hasil Uji Parsial dan Penuh (slide lama, kalimat diperbaiki).pptx
@@ -900,7 +900,7 @@
           <a:lstStyle/>
           <a:p>
             <a:r>
-              <a:t>Pada uji parsial, input dari subsistem lain diganti data aktual, sehingga yang dinilai hanya struktur subsistem itu sendiri. Hasilnya, subsistem akomodasi paling baik: jumlah hotel lolos uji tren, E1, dan E2 dengan DC 0,2011. P1b sebagai uji kekokohan P1 memberi pola serupa. Seluruh MAPE di bawah 20 persen. Satu-satunya yang gagal uji tren adalah subsistem wisatawan: simulasi tumbuh sekitar 6,4 persen per tahun, sedangkan data sekitar 11,7 persen. Selisihnya sistematis, bukan acak, sehingga penyebabnya ditelusuri lewat kalibrasi.</a:t>
+              <a:t>Pada uji parsial, input dari subsistem lain diganti data aktual, sehingga yang dinilai hanya struktur subsistem itu sendiri. Hasilnya, subsistem akomodasi paling baik: jumlah hotel lolos uji tren, E1, dan E2 dengan DC 0,2011. P1b sebagai uji kekokohan P1 memberi pola serupa. Seluruh MAPE di bawah 20 persen. Satu-satunya yang gagal uji tren adalah subsistem wisatawan: simulasi tumbuh sekitar 6,4 persen per tahun, sedangkan data sekitar 11,7 persen, sehingga simulasi makin tertinggal. Selisihnya berpola, bukan kebetulan, sehingga penyebabnya ditelusuri lewat kalibrasi.</a:t>
             </a:r>
           </a:p>
         </p:txBody>
@@ -1111,7 +1111,7 @@
           <a:lstStyle/>
           <a:p>
             <a:r>
-              <a:t>Pada uji penuh, model dijalankan tanpa penggantian data sehingga semua subsistem saling memengaruhi. Grafik ini membandingkan DC uji parsial dan uji penuh. DC hotel naik dari 0,20 menjadi 0,82, ODTW dari 0,34 menjadi 0,79, dan tenaga kerja dari 0,49 menjadi 0,89. Ini bukan karena struktur subsistemnya salah, tetapi karena jumlah wisatawan tumbuh lebih lambat dari data, sehingga pengeluaran, PDRB, dan investasi ikut rendah, lalu hotel dan ODTW yang dibangun lebih sedikit. TPK justru membaik. Dari sisi besaran error, MAPE tetap wajar: ODTW sangat baik, lima variabel baik, tiga variabel ekonomi layak, dan tidak ada yang buruk. U1 dominan pada enam dari sembilan variabel, artinya error berasal dari satu sumber bersama, yaitu pertumbuhan wisatawan.</a:t>
+              <a:t>Pada uji penuh, model dijalankan tanpa penggantian data sehingga semua subsistem saling memengaruhi. Grafik ini membandingkan DC uji parsial dan uji penuh. DC hotel naik dari 0,20 menjadi 0,82, ODTW dari 0,34 menjadi 0,79, dan tenaga kerja dari 0,49 menjadi 0,89. Ini bukan karena struktur subsistemnya salah, tetapi karena jumlah wisatawan tumbuh lebih lambat dari data, sehingga pengeluaran, PDRB, dan investasi ikut rendah, lalu hotel dan ODTW yang dibangun lebih sedikit. TPK justru membaik. Dari sisi besaran error, MAPE tetap wajar: ODTW sangat baik, lima variabel baik, tiga variabel ekonomi layak, dan tidak ada yang buruk. Pada enam dari sembilan variabel, selisih terbesarnya berasal dari beda rata-rata atau U1, tanda bahwa sumbernya sama, yaitu pertumbuhan wisatawan.</a:t>
             </a:r>
           </a:p>
         </p:txBody>
@@ -11198,7 +11198,7 @@
                   <a:cs typeface="Calibri (MS)"/>
                   <a:sym typeface="Calibri (MS)"/>
                 </a:rPr>
-                <a:t>Simulasi tumbuh ≈6,4% per tahun, sedangkan data ≈11,7% per tahun. Selisihnya sistematis (U1+U2 ≈ 0,96), bukan acak, sehingga ditelusuri lewat kalibrasi.</a:t>
+                <a:t>Simulasi tumbuh sekitar 6,4% per tahun, sedangkan data sekitar 11,7% per tahun, sehingga simulasi makin tertinggal dari data. Selisihnya berpola, bukan kebetulan (U1+U2 ≈ 0,96), jadi penyebabnya ditelusuri lewat kalibrasi.</a:t>
               </a:r>
             </a:p>
           </p:txBody>
@@ -11376,7 +11376,7 @@
                   <a:cs typeface="Calibri (MS)"/>
                   <a:sym typeface="Calibri (MS)"/>
                 </a:rPr>
-                <a:t>Saat input dari subsistem lain diganti data aktual, tiap subsistem dapat mengikuti pola datanya (MAPE seluruhnya &lt; 20%); kelemahan hanya ada pada subsistem wisatawan.</a:t>
+                <a:t>Saat diuji sendiri-sendiri, setiap subsistem menghasilkan simulasi yang dekat dengan data (selisih rata-rata/MAPE &lt; 20%); satu-satunya yang bermasalah adalah subsistem wisatawan, yang tumbuh lebih lambat dari data.</a:t>
               </a:r>
             </a:p>
           </p:txBody>
@@ -14802,7 +14802,7 @@
                   <a:cs typeface="Calibri (MS)"/>
                   <a:sym typeface="Calibri (MS)"/>
                 </a:rPr>
-                <a:t>Mengapa melemah? Wisatawan tumbuh lebih lambat dari data → pengeluaran, PDRB, dan investasi ikut rendah → hotel dan ODTW yang dibangun lebih sedikit. U1 dominan pada 6 dari 9 variabel: error dari satu sumber.</a:t>
+                <a:t>Mengapa melemah? Wisatawan tumbuh lebih lambat dari data → pengeluaran, PDRB, dan investasi ikut rendah → hotel dan ODTW yang dibangun lebih sedikit. Pada 6 dari 9 variabel, selisih terbesar berasal dari beda rata-rata (U1): tanda sumbernya sama.</a:t>
               </a:r>
             </a:p>
           </p:txBody>

</xml_diff>